<commit_message>
docs: pin Loom video URL into README + PPT slides 6 & 7
Video recorded and made public:
https://www.loom.com/share/b10268c4694f4a8f8cf5e7292aef7a21
Duration 2:53 — inside the 3-min cap and the brief's 4-min ceiling.

Updated:
- README 'Live demo' section now lists app URL + Loom + repo.
- presentation/Receipt-to-Cashback.pptx slide 6 (Demo) and slide 7
  (Links — PSTB Team Only) regenerated with the Loom URL in place.

Co-Authored-By: Claude Opus 4.7 (1M context) <noreply@anthropic.com>
</commit_message>
<xml_diff>
--- a/presentation/Receipt-to-Cashback.pptx
+++ b/presentation/Receipt-to-Cashback.pptx
@@ -12100,7 +12100,7 @@
           <a:p>
             <a:r>
               <a:rPr/>
-              <a:t>Loom video (3 min): [WILL BE ADDED AFTER RECORDING — see docs/05_demo_script.md]</a:t>
+              <a:t>Loom video (2:53): https://www.loom.com/share/b10268c4694f4a8f8cf5e7292aef7a21</a:t>
             </a:r>
           </a:p>
         </p:txBody>
@@ -12217,7 +12217,7 @@
           <a:p>
             <a:r>
               <a:rPr/>
-              <a:t>3-min video (Loom): [WILL BE ADDED AFTER RECORDING]</a:t>
+              <a:t>Demo video (Loom, 2:53): https://www.loom.com/share/b10268c4694f4a8f8cf5e7292aef7a21</a:t>
             </a:r>
           </a:p>
           <a:p>

</xml_diff>